<commit_message>
Mejoras en el ppt
</commit_message>
<xml_diff>
--- a/inst/plantillas/plantilla_16_9.pptx
+++ b/inst/plantillas/plantilla_16_9.pptx
@@ -346,7 +346,7 @@
           <a:p>
             <a:fld id="{A9DF37BE-63F7-D04E-AEC4-DC43A32AA23E}" type="datetimeFigureOut">
               <a:rPr lang="en-PE" smtClean="0"/>
-              <a:t>18/02/26</a:t>
+              <a:t>13/03/26</a:t>
             </a:fld>
             <a:endParaRPr lang="en-PE"/>
           </a:p>
@@ -523,7 +523,7 @@
           <a:p>
             <a:fld id="{EE8340E0-AD77-4043-A3C3-5BEDD4FD6B77}" type="datetimeFigureOut">
               <a:rPr lang="es-PE" smtClean="0"/>
-              <a:t>18/02/26</a:t>
+              <a:t>13/03/26</a:t>
             </a:fld>
             <a:endParaRPr lang="es-PE"/>
           </a:p>
@@ -1323,7 +1323,7 @@
                 </a:buClr>
                 <a:buSzPts val="1800"/>
               </a:pPr>
-              <a:t>18/02/26</a:t>
+              <a:t>13/03/26</a:t>
             </a:fld>
             <a:endParaRPr lang="en-PE" dirty="0"/>
           </a:p>
@@ -9886,7 +9886,7 @@
           <a:p>
             <a:fld id="{744CB4CB-0240-FB4C-81F1-218533927016}" type="datetimeFigureOut">
               <a:rPr lang="es-PE" smtClean="0"/>
-              <a:t>18/02/26</a:t>
+              <a:t>13/03/26</a:t>
             </a:fld>
             <a:endParaRPr lang="es-PE"/>
           </a:p>
@@ -15486,7 +15486,7 @@
         <p:spPr>
           <a:xfrm>
             <a:off x="288235" y="195961"/>
-            <a:ext cx="9799981" cy="818842"/>
+            <a:ext cx="9799981" cy="540000"/>
           </a:xfrm>
         </p:spPr>
         <p:txBody>
@@ -15630,7 +15630,7 @@
         <p:spPr>
           <a:xfrm>
             <a:off x="317500" y="119062"/>
-            <a:ext cx="9730221" cy="846037"/>
+            <a:ext cx="9730221" cy="540000"/>
           </a:xfrm>
         </p:spPr>
         <p:txBody>
@@ -17958,7 +17958,7 @@
           <a:p>
             <a:fld id="{75C70C58-02E6-BE4A-9320-917330A400ED}" type="datetimeFigureOut">
               <a:rPr lang="es-PE" smtClean="0"/>
-              <a:t>18/02/26</a:t>
+              <a:t>13/03/26</a:t>
             </a:fld>
             <a:endParaRPr lang="es-PE"/>
           </a:p>

</xml_diff>